<commit_message>
Arabic coffee: drop the redundant defaults.run.color so the native table header keeps its drawn colour
defaults.run.color resolved before style.header_text, so the native export
painted the header runs #2B1D15 on the #4A2C1D header band while the SVG
draws them #F6EFE4. style.body_text already carries #2B1D15 for body cells.
Both exports are rebuilt; the header runs now export as F6EFE4.

Co-Authored-By: Claude Fable 5.1 <noreply@anthropic.com>
Claude-Session: https://claude.ai/code/session_01Eq2teFYQN42gQBLKGur5HD
</commit_message>
<xml_diff>
--- a/examples/ppt169_arabic_coffee_ar/exports/ppt169_arabic_coffee_ar.pptx
+++ b/examples/ppt169_arabic_coffee_ar/exports/ppt169_arabic_coffee_ar.pptx
@@ -31,7 +31,7 @@
       <a:defRPr lang="ar-SA"/>
     </a:defPPr>
     <a:lvl1pPr marL="0" algn="r" defTabSz="457200" rtl="1" eaLnBrk="1" latinLnBrk="0" hangingPunct="1">
-      <a:defRPr sz="1800" kern="1200">
+      <a:defRPr sz="1800" kern="1200" lang="ar-SA">
         <a:solidFill>
           <a:schemeClr val="tx1"/>
         </a:solidFill>
@@ -41,7 +41,7 @@
       </a:defRPr>
     </a:lvl1pPr>
     <a:lvl2pPr marL="457200" algn="r" defTabSz="457200" rtl="1" eaLnBrk="1" latinLnBrk="0" hangingPunct="1">
-      <a:defRPr sz="1800" kern="1200">
+      <a:defRPr sz="1800" kern="1200" lang="ar-SA">
         <a:solidFill>
           <a:schemeClr val="tx1"/>
         </a:solidFill>
@@ -51,7 +51,7 @@
       </a:defRPr>
     </a:lvl2pPr>
     <a:lvl3pPr marL="914400" algn="r" defTabSz="457200" rtl="1" eaLnBrk="1" latinLnBrk="0" hangingPunct="1">
-      <a:defRPr sz="1800" kern="1200">
+      <a:defRPr sz="1800" kern="1200" lang="ar-SA">
         <a:solidFill>
           <a:schemeClr val="tx1"/>
         </a:solidFill>
@@ -61,7 +61,7 @@
       </a:defRPr>
     </a:lvl3pPr>
     <a:lvl4pPr marL="1371600" algn="r" defTabSz="457200" rtl="1" eaLnBrk="1" latinLnBrk="0" hangingPunct="1">
-      <a:defRPr sz="1800" kern="1200">
+      <a:defRPr sz="1800" kern="1200" lang="ar-SA">
         <a:solidFill>
           <a:schemeClr val="tx1"/>
         </a:solidFill>
@@ -71,7 +71,7 @@
       </a:defRPr>
     </a:lvl4pPr>
     <a:lvl5pPr marL="1828800" algn="r" defTabSz="457200" rtl="1" eaLnBrk="1" latinLnBrk="0" hangingPunct="1">
-      <a:defRPr sz="1800" kern="1200">
+      <a:defRPr sz="1800" kern="1200" lang="ar-SA">
         <a:solidFill>
           <a:schemeClr val="tx1"/>
         </a:solidFill>
@@ -81,7 +81,7 @@
       </a:defRPr>
     </a:lvl5pPr>
     <a:lvl6pPr marL="2286000" algn="r" defTabSz="457200" rtl="1" eaLnBrk="1" latinLnBrk="0" hangingPunct="1">
-      <a:defRPr sz="1800" kern="1200">
+      <a:defRPr sz="1800" kern="1200" lang="ar-SA">
         <a:solidFill>
           <a:schemeClr val="tx1"/>
         </a:solidFill>
@@ -91,7 +91,7 @@
       </a:defRPr>
     </a:lvl6pPr>
     <a:lvl7pPr marL="2743200" algn="r" defTabSz="457200" rtl="1" eaLnBrk="1" latinLnBrk="0" hangingPunct="1">
-      <a:defRPr sz="1800" kern="1200">
+      <a:defRPr sz="1800" kern="1200" lang="ar-SA">
         <a:solidFill>
           <a:schemeClr val="tx1"/>
         </a:solidFill>
@@ -101,7 +101,7 @@
       </a:defRPr>
     </a:lvl7pPr>
     <a:lvl8pPr marL="3200400" algn="r" defTabSz="457200" rtl="1" eaLnBrk="1" latinLnBrk="0" hangingPunct="1">
-      <a:defRPr sz="1800" kern="1200">
+      <a:defRPr sz="1800" kern="1200" lang="ar-SA">
         <a:solidFill>
           <a:schemeClr val="tx1"/>
         </a:solidFill>
@@ -111,7 +111,7 @@
       </a:defRPr>
     </a:lvl8pPr>
     <a:lvl9pPr marL="3657600" algn="r" defTabSz="457200" rtl="1" eaLnBrk="1" latinLnBrk="0" hangingPunct="1">
-      <a:defRPr sz="1800" kern="1200">
+      <a:defRPr sz="1800" kern="1200" lang="ar-SA">
         <a:solidFill>
           <a:schemeClr val="tx1"/>
         </a:solidFill>
@@ -1378,7 +1378,7 @@
           <a:bodyPr vert="horz" lIns="91440" tIns="45720" rIns="91440" bIns="45720" rtlCol="0" anchor="ctr"/>
           <a:lstStyle>
             <a:lvl1pPr algn="l">
-              <a:defRPr sz="1200">
+              <a:defRPr sz="1200" lang="ar-SA">
                 <a:solidFill>
                   <a:schemeClr val="tx1">
                     <a:tint val="75000"/>
@@ -1419,7 +1419,7 @@
           <a:bodyPr vert="horz" lIns="91440" tIns="45720" rIns="91440" bIns="45720" rtlCol="0" anchor="ctr"/>
           <a:lstStyle>
             <a:lvl1pPr algn="ctr">
-              <a:defRPr sz="1200">
+              <a:defRPr sz="1200" lang="ar-SA">
                 <a:solidFill>
                   <a:schemeClr val="tx1">
                     <a:tint val="75000"/>
@@ -1456,7 +1456,7 @@
           <a:bodyPr vert="horz" lIns="91440" tIns="45720" rIns="91440" bIns="45720" rtlCol="0" anchor="ctr"/>
           <a:lstStyle>
             <a:lvl1pPr algn="r">
-              <a:defRPr sz="1200">
+              <a:defRPr sz="1200" lang="ar-SA">
                 <a:solidFill>
                   <a:schemeClr val="tx1">
                     <a:tint val="75000"/>
@@ -1487,7 +1487,7 @@
           <a:spcPct val="0"/>
         </a:spcBef>
         <a:buNone/>
-        <a:defRPr sz="3600" kern="1200">
+        <a:defRPr sz="3600" kern="1200" lang="ar-SA">
           <a:solidFill>
             <a:schemeClr val="tx1"/>
           </a:solidFill>
@@ -1504,7 +1504,7 @@
         </a:spcBef>
         <a:buFont typeface="Arial"/>
         <a:buChar char="•"/>
-        <a:defRPr sz="1950" kern="1200">
+        <a:defRPr sz="1950" kern="1200" lang="ar-SA">
           <a:solidFill>
             <a:schemeClr val="tx1"/>
           </a:solidFill>
@@ -1519,7 +1519,7 @@
         </a:spcBef>
         <a:buFont typeface="Arial"/>
         <a:buChar char="–"/>
-        <a:defRPr sz="1850" kern="1200">
+        <a:defRPr sz="1850" kern="1200" lang="ar-SA">
           <a:solidFill>
             <a:schemeClr val="tx1"/>
           </a:solidFill>
@@ -1534,7 +1534,7 @@
         </a:spcBef>
         <a:buFont typeface="Arial"/>
         <a:buChar char="•"/>
-        <a:defRPr sz="1700" kern="1200">
+        <a:defRPr sz="1700" kern="1200" lang="ar-SA">
           <a:solidFill>
             <a:schemeClr val="tx1"/>
           </a:solidFill>
@@ -1549,7 +1549,7 @@
         </a:spcBef>
         <a:buFont typeface="Arial"/>
         <a:buChar char="–"/>
-        <a:defRPr sz="1600" kern="1200">
+        <a:defRPr sz="1600" kern="1200" lang="ar-SA">
           <a:solidFill>
             <a:schemeClr val="tx1"/>
           </a:solidFill>
@@ -1564,7 +1564,7 @@
         </a:spcBef>
         <a:buFont typeface="Arial"/>
         <a:buChar char="»"/>
-        <a:defRPr sz="1450" kern="1200">
+        <a:defRPr sz="1450" kern="1200" lang="ar-SA">
           <a:solidFill>
             <a:schemeClr val="tx1"/>
           </a:solidFill>
@@ -1579,7 +1579,7 @@
         </a:spcBef>
         <a:buFont typeface="Arial"/>
         <a:buChar char="•"/>
-        <a:defRPr sz="1350" kern="1200">
+        <a:defRPr sz="1350" kern="1200" lang="ar-SA">
           <a:solidFill>
             <a:schemeClr val="tx1"/>
           </a:solidFill>
@@ -1594,7 +1594,7 @@
         </a:spcBef>
         <a:buFont typeface="Arial"/>
         <a:buChar char="•"/>
-        <a:defRPr sz="1200" kern="1200">
+        <a:defRPr sz="1200" kern="1200" lang="ar-SA">
           <a:solidFill>
             <a:schemeClr val="tx1"/>
           </a:solidFill>
@@ -1609,7 +1609,7 @@
         </a:spcBef>
         <a:buFont typeface="Arial"/>
         <a:buChar char="•"/>
-        <a:defRPr sz="1100" kern="1200">
+        <a:defRPr sz="1100" kern="1200" lang="ar-SA">
           <a:solidFill>
             <a:schemeClr val="tx1"/>
           </a:solidFill>
@@ -1624,7 +1624,7 @@
         </a:spcBef>
         <a:buFont typeface="Arial"/>
         <a:buChar char="•"/>
-        <a:defRPr sz="1000" kern="1200">
+        <a:defRPr sz="1000" kern="1200" lang="ar-SA">
           <a:solidFill>
             <a:schemeClr val="tx1"/>
           </a:solidFill>
@@ -1639,7 +1639,7 @@
         <a:defRPr lang="ar-SA"/>
       </a:defPPr>
       <a:lvl1pPr marL="0" algn="r" defTabSz="457200" rtl="1" eaLnBrk="1" latinLnBrk="0" hangingPunct="1">
-        <a:defRPr sz="1950" kern="1200">
+        <a:defRPr sz="1950" kern="1200" lang="ar-SA">
           <a:solidFill>
             <a:schemeClr val="tx1"/>
           </a:solidFill>
@@ -1649,7 +1649,7 @@
         </a:defRPr>
       </a:lvl1pPr>
       <a:lvl2pPr marL="457200" algn="r" defTabSz="457200" rtl="1" eaLnBrk="1" latinLnBrk="0" hangingPunct="1">
-        <a:defRPr sz="1850" kern="1200">
+        <a:defRPr sz="1850" kern="1200" lang="ar-SA">
           <a:solidFill>
             <a:schemeClr val="tx1"/>
           </a:solidFill>
@@ -1659,7 +1659,7 @@
         </a:defRPr>
       </a:lvl2pPr>
       <a:lvl3pPr marL="914400" algn="r" defTabSz="457200" rtl="1" eaLnBrk="1" latinLnBrk="0" hangingPunct="1">
-        <a:defRPr sz="1700" kern="1200">
+        <a:defRPr sz="1700" kern="1200" lang="ar-SA">
           <a:solidFill>
             <a:schemeClr val="tx1"/>
           </a:solidFill>
@@ -1669,7 +1669,7 @@
         </a:defRPr>
       </a:lvl3pPr>
       <a:lvl4pPr marL="1371600" algn="r" defTabSz="457200" rtl="1" eaLnBrk="1" latinLnBrk="0" hangingPunct="1">
-        <a:defRPr sz="1600" kern="1200">
+        <a:defRPr sz="1600" kern="1200" lang="ar-SA">
           <a:solidFill>
             <a:schemeClr val="tx1"/>
           </a:solidFill>
@@ -1679,7 +1679,7 @@
         </a:defRPr>
       </a:lvl4pPr>
       <a:lvl5pPr marL="1828800" algn="r" defTabSz="457200" rtl="1" eaLnBrk="1" latinLnBrk="0" hangingPunct="1">
-        <a:defRPr sz="1450" kern="1200">
+        <a:defRPr sz="1450" kern="1200" lang="ar-SA">
           <a:solidFill>
             <a:schemeClr val="tx1"/>
           </a:solidFill>
@@ -1689,7 +1689,7 @@
         </a:defRPr>
       </a:lvl5pPr>
       <a:lvl6pPr marL="2286000" algn="r" defTabSz="457200" rtl="1" eaLnBrk="1" latinLnBrk="0" hangingPunct="1">
-        <a:defRPr sz="1350" kern="1200">
+        <a:defRPr sz="1350" kern="1200" lang="ar-SA">
           <a:solidFill>
             <a:schemeClr val="tx1"/>
           </a:solidFill>
@@ -1699,7 +1699,7 @@
         </a:defRPr>
       </a:lvl6pPr>
       <a:lvl7pPr marL="2743200" algn="r" defTabSz="457200" rtl="1" eaLnBrk="1" latinLnBrk="0" hangingPunct="1">
-        <a:defRPr sz="1200" kern="1200">
+        <a:defRPr sz="1200" kern="1200" lang="ar-SA">
           <a:solidFill>
             <a:schemeClr val="tx1"/>
           </a:solidFill>
@@ -1709,7 +1709,7 @@
         </a:defRPr>
       </a:lvl7pPr>
       <a:lvl8pPr marL="3200400" algn="r" defTabSz="457200" rtl="1" eaLnBrk="1" latinLnBrk="0" hangingPunct="1">
-        <a:defRPr sz="1100" kern="1200">
+        <a:defRPr sz="1100" kern="1200" lang="ar-SA">
           <a:solidFill>
             <a:schemeClr val="tx1"/>
           </a:solidFill>
@@ -1719,7 +1719,7 @@
         </a:defRPr>
       </a:lvl8pPr>
       <a:lvl9pPr marL="3657600" algn="r" defTabSz="457200" rtl="1" eaLnBrk="1" latinLnBrk="0" hangingPunct="1">
-        <a:defRPr sz="1000" kern="1200">
+        <a:defRPr sz="1000" kern="1200" lang="ar-SA">
           <a:solidFill>
             <a:schemeClr val="tx1"/>
           </a:solidFill>

</xml_diff>